<commit_message>
WIP: audit reports for U2 S2.1 and S2.3; final wording fixes in progress
Co-Authored-By: Claude Sonnet 5.5 <noreply@anthropic.com>
Claude-Session: https://claude.ai/code/session_01CAqidLLu6PiYNMcZx5qMsE
</commit_message>
<xml_diff>
--- a/deliverables/chem-u02/SHULL_CHEM_Slides_U02_S02.5.pptx
+++ b/deliverables/chem-u02/SHULL_CHEM_Slides_U02_S02.5.pptx
@@ -21524,7 +21524,7 @@
                 <a:ea typeface="Trade Gothic Next" pitchFamily="34" charset="-122"/>
                 <a:cs typeface="Trade Gothic Next" pitchFamily="34" charset="-120"/>
               </a:rPr>
-              <a:t>Four lines, computed from the energy levels.</a:t>
+              <a:t>Four lines, from the energy levels.</a:t>
             </a:r>
             <a:endParaRPr lang="en-US" sz="1700" dirty="0"/>
           </a:p>
@@ -22177,7 +22177,7 @@
                 <a:ea typeface="Trade Gothic Next" pitchFamily="34" charset="-122"/>
                 <a:cs typeface="Trade Gothic Next" pitchFamily="34" charset="-120"/>
               </a:rPr>
-              <a:t>The drop releases one photon with energy ΔE.</a:t>
+              <a:t>The drop releases one photon of light. That is the energy released.</a:t>
             </a:r>
             <a:endParaRPr lang="en-US" sz="1600" dirty="0"/>
           </a:p>

</xml_diff>